<commit_message>
Update plotter UI/rule indicators and align Rule 10 model/wiki outputs
</commit_message>
<xml_diff>
--- a/notes/New Microsoft PowerPoint Presentation.pptx
+++ b/notes/New Microsoft PowerPoint Presentation.pptx
@@ -115,20 +115,12 @@
 </p:presentation>
 </file>
 
-<file path=ppt/revisionInfo.xml><?xml version="1.0" encoding="utf-8"?>
-<p1510:revInfo xmlns:a="http://schemas.openxmlformats.org/drawingml/2006/main" xmlns:r="http://schemas.openxmlformats.org/officeDocument/2006/relationships" xmlns:p1510="http://schemas.microsoft.com/office/powerpoint/2015/10/main">
-  <p1510:revLst>
-    <p1510:client id="{ED69A44D-24AC-4A36-8512-3944251D8366}" v="1" dt="2026-05-07T18:28:05.914"/>
-  </p1510:revLst>
-</p1510:revInfo>
-</file>
-
 <file path=ppt/changesInfos/changesInfo1.xml><?xml version="1.0" encoding="utf-8"?>
 <pc:chgInfo xmlns:a="http://schemas.openxmlformats.org/drawingml/2006/main" xmlns:r="http://schemas.openxmlformats.org/officeDocument/2006/relationships" xmlns:ac="http://schemas.microsoft.com/office/drawing/2013/main/command" xmlns:pc="http://schemas.microsoft.com/office/powerpoint/2013/main/command">
   <pc:docChgLst>
     <pc:chgData name="Lindeman, Mark A (US 365H)" userId="3688c61a-c847-421f-97e7-31f196fb4491" providerId="ADAL" clId="{216A9E4E-1227-49C0-8A78-42279DBF0FD8}"/>
     <pc:docChg chg="custSel addSld modSld">
-      <pc:chgData name="Lindeman, Mark A (US 365H)" userId="3688c61a-c847-421f-97e7-31f196fb4491" providerId="ADAL" clId="{216A9E4E-1227-49C0-8A78-42279DBF0FD8}" dt="2026-05-07T18:28:19.497" v="556" actId="20577"/>
+      <pc:chgData name="Lindeman, Mark A (US 365H)" userId="3688c61a-c847-421f-97e7-31f196fb4491" providerId="ADAL" clId="{216A9E4E-1227-49C0-8A78-42279DBF0FD8}" dt="2026-05-14T23:35:53.194" v="560" actId="1076"/>
       <pc:docMkLst>
         <pc:docMk/>
       </pc:docMkLst>
@@ -147,8 +139,8 @@
           </ac:spMkLst>
         </pc:spChg>
       </pc:sldChg>
-      <pc:sldChg chg="addSp modSp new mod">
-        <pc:chgData name="Lindeman, Mark A (US 365H)" userId="3688c61a-c847-421f-97e7-31f196fb4491" providerId="ADAL" clId="{216A9E4E-1227-49C0-8A78-42279DBF0FD8}" dt="2026-05-06T21:44:01.808" v="39" actId="20577"/>
+      <pc:sldChg chg="addSp delSp modSp new mod">
+        <pc:chgData name="Lindeman, Mark A (US 365H)" userId="3688c61a-c847-421f-97e7-31f196fb4491" providerId="ADAL" clId="{216A9E4E-1227-49C0-8A78-42279DBF0FD8}" dt="2026-05-14T23:35:53.194" v="560" actId="1076"/>
         <pc:sldMkLst>
           <pc:docMk/>
           <pc:sldMk cId="412030553" sldId="257"/>
@@ -169,12 +161,20 @@
             <ac:spMk id="3" creationId="{FC94D0CA-6921-7260-B245-4A3CBE1CDCF4}"/>
           </ac:spMkLst>
         </pc:spChg>
-        <pc:picChg chg="add mod">
-          <ac:chgData name="Lindeman, Mark A (US 365H)" userId="3688c61a-c847-421f-97e7-31f196fb4491" providerId="ADAL" clId="{216A9E4E-1227-49C0-8A78-42279DBF0FD8}" dt="2026-05-06T21:43:56.938" v="25" actId="14100"/>
+        <pc:picChg chg="add del mod">
+          <ac:chgData name="Lindeman, Mark A (US 365H)" userId="3688c61a-c847-421f-97e7-31f196fb4491" providerId="ADAL" clId="{216A9E4E-1227-49C0-8A78-42279DBF0FD8}" dt="2026-05-14T23:35:47.110" v="557" actId="478"/>
           <ac:picMkLst>
             <pc:docMk/>
             <pc:sldMk cId="412030553" sldId="257"/>
             <ac:picMk id="5" creationId="{17DFC289-86C3-CCBD-24F7-6E9CE935C07E}"/>
+          </ac:picMkLst>
+        </pc:picChg>
+        <pc:picChg chg="add mod">
+          <ac:chgData name="Lindeman, Mark A (US 365H)" userId="3688c61a-c847-421f-97e7-31f196fb4491" providerId="ADAL" clId="{216A9E4E-1227-49C0-8A78-42279DBF0FD8}" dt="2026-05-14T23:35:53.194" v="560" actId="1076"/>
+          <ac:picMkLst>
+            <pc:docMk/>
+            <pc:sldMk cId="412030553" sldId="257"/>
+            <ac:picMk id="6" creationId="{6FA77D13-4DB9-2E4D-8CC4-3979CE819696}"/>
           </ac:picMkLst>
         </pc:picChg>
       </pc:sldChg>
@@ -368,7 +368,7 @@
           <a:p>
             <a:fld id="{5634BD14-1F87-4944-B08D-D3EC23AB331F}" type="datetimeFigureOut">
               <a:rPr lang="en-US" smtClean="0"/>
-              <a:t>5/7/2026</a:t>
+              <a:t>5/14/2026</a:t>
             </a:fld>
             <a:endParaRPr lang="en-US"/>
           </a:p>
@@ -566,7 +566,7 @@
           <a:p>
             <a:fld id="{5634BD14-1F87-4944-B08D-D3EC23AB331F}" type="datetimeFigureOut">
               <a:rPr lang="en-US" smtClean="0"/>
-              <a:t>5/7/2026</a:t>
+              <a:t>5/14/2026</a:t>
             </a:fld>
             <a:endParaRPr lang="en-US"/>
           </a:p>
@@ -774,7 +774,7 @@
           <a:p>
             <a:fld id="{5634BD14-1F87-4944-B08D-D3EC23AB331F}" type="datetimeFigureOut">
               <a:rPr lang="en-US" smtClean="0"/>
-              <a:t>5/7/2026</a:t>
+              <a:t>5/14/2026</a:t>
             </a:fld>
             <a:endParaRPr lang="en-US"/>
           </a:p>
@@ -972,7 +972,7 @@
           <a:p>
             <a:fld id="{5634BD14-1F87-4944-B08D-D3EC23AB331F}" type="datetimeFigureOut">
               <a:rPr lang="en-US" smtClean="0"/>
-              <a:t>5/7/2026</a:t>
+              <a:t>5/14/2026</a:t>
             </a:fld>
             <a:endParaRPr lang="en-US"/>
           </a:p>
@@ -1247,7 +1247,7 @@
           <a:p>
             <a:fld id="{5634BD14-1F87-4944-B08D-D3EC23AB331F}" type="datetimeFigureOut">
               <a:rPr lang="en-US" smtClean="0"/>
-              <a:t>5/7/2026</a:t>
+              <a:t>5/14/2026</a:t>
             </a:fld>
             <a:endParaRPr lang="en-US"/>
           </a:p>
@@ -1512,7 +1512,7 @@
           <a:p>
             <a:fld id="{5634BD14-1F87-4944-B08D-D3EC23AB331F}" type="datetimeFigureOut">
               <a:rPr lang="en-US" smtClean="0"/>
-              <a:t>5/7/2026</a:t>
+              <a:t>5/14/2026</a:t>
             </a:fld>
             <a:endParaRPr lang="en-US"/>
           </a:p>
@@ -1924,7 +1924,7 @@
           <a:p>
             <a:fld id="{5634BD14-1F87-4944-B08D-D3EC23AB331F}" type="datetimeFigureOut">
               <a:rPr lang="en-US" smtClean="0"/>
-              <a:t>5/7/2026</a:t>
+              <a:t>5/14/2026</a:t>
             </a:fld>
             <a:endParaRPr lang="en-US"/>
           </a:p>
@@ -2065,7 +2065,7 @@
           <a:p>
             <a:fld id="{5634BD14-1F87-4944-B08D-D3EC23AB331F}" type="datetimeFigureOut">
               <a:rPr lang="en-US" smtClean="0"/>
-              <a:t>5/7/2026</a:t>
+              <a:t>5/14/2026</a:t>
             </a:fld>
             <a:endParaRPr lang="en-US"/>
           </a:p>
@@ -2178,7 +2178,7 @@
           <a:p>
             <a:fld id="{5634BD14-1F87-4944-B08D-D3EC23AB331F}" type="datetimeFigureOut">
               <a:rPr lang="en-US" smtClean="0"/>
-              <a:t>5/7/2026</a:t>
+              <a:t>5/14/2026</a:t>
             </a:fld>
             <a:endParaRPr lang="en-US"/>
           </a:p>
@@ -2489,7 +2489,7 @@
           <a:p>
             <a:fld id="{5634BD14-1F87-4944-B08D-D3EC23AB331F}" type="datetimeFigureOut">
               <a:rPr lang="en-US" smtClean="0"/>
-              <a:t>5/7/2026</a:t>
+              <a:t>5/14/2026</a:t>
             </a:fld>
             <a:endParaRPr lang="en-US"/>
           </a:p>
@@ -2777,7 +2777,7 @@
           <a:p>
             <a:fld id="{5634BD14-1F87-4944-B08D-D3EC23AB331F}" type="datetimeFigureOut">
               <a:rPr lang="en-US" smtClean="0"/>
-              <a:t>5/7/2026</a:t>
+              <a:t>5/14/2026</a:t>
             </a:fld>
             <a:endParaRPr lang="en-US"/>
           </a:p>
@@ -3018,7 +3018,7 @@
           <a:p>
             <a:fld id="{5634BD14-1F87-4944-B08D-D3EC23AB331F}" type="datetimeFigureOut">
               <a:rPr lang="en-US" smtClean="0"/>
-              <a:t>5/7/2026</a:t>
+              <a:t>5/14/2026</a:t>
             </a:fld>
             <a:endParaRPr lang="en-US"/>
           </a:p>
@@ -3583,10 +3583,10 @@
       </p:sp>
       <p:pic>
         <p:nvPicPr>
-          <p:cNvPr id="5" name="Picture 4">
-            <a:extLst>
-              <a:ext uri="{FF2B5EF4-FFF2-40B4-BE49-F238E27FC236}">
-                <a16:creationId xmlns:a16="http://schemas.microsoft.com/office/drawing/2014/main" id="{17DFC289-86C3-CCBD-24F7-6E9CE935C07E}"/>
+          <p:cNvPr id="6" name="Picture 5">
+            <a:extLst>
+              <a:ext uri="{FF2B5EF4-FFF2-40B4-BE49-F238E27FC236}">
+                <a16:creationId xmlns:a16="http://schemas.microsoft.com/office/drawing/2014/main" id="{6FA77D13-4DB9-2E4D-8CC4-3979CE819696}"/>
               </a:ext>
             </a:extLst>
           </p:cNvPr>
@@ -3603,8 +3603,8 @@
         </p:blipFill>
         <p:spPr>
           <a:xfrm>
-            <a:off x="3742134" y="2143760"/>
-            <a:ext cx="8449866" cy="4613731"/>
+            <a:off x="3823647" y="1196052"/>
+            <a:ext cx="6056954" cy="5242847"/>
           </a:xfrm>
           <a:prstGeom prst="rect">
             <a:avLst/>

</xml_diff>